<commit_message>
feat: final presentation updates and README (Agent 5 v2)
Co-Authored-By: Claude Sonnet 4.6 <noreply@anthropic.com>
</commit_message>
<xml_diff>
--- a/presentations/swedish_municipality_explorer.pptx
+++ b/presentations/swedish_municipality_explorer.pptx
@@ -3111,8 +3111,8 @@
         </p:nvSpPr>
         <p:spPr>
           <a:xfrm>
-            <a:off x="548640" y="685800"/>
-            <a:ext cx="11091672" cy="822960"/>
+            <a:off x="548640" y="411480"/>
+            <a:ext cx="11091672" cy="777240"/>
           </a:xfrm>
           <a:prstGeom prst="rect">
             <a:avLst/>
@@ -3131,7 +3131,7 @@
               </a:spcAft>
             </a:pPr>
             <a:r>
-              <a:rPr sz="4000" b="1" i="0">
+              <a:rPr sz="3600" b="1" i="0">
                 <a:solidFill>
                   <a:srgbClr val="8B7355"/>
                 </a:solidFill>
@@ -3150,8 +3150,8 @@
         </p:nvSpPr>
         <p:spPr>
           <a:xfrm>
-            <a:off x="548640" y="1508760"/>
-            <a:ext cx="11091672" cy="457200"/>
+            <a:off x="548640" y="1143000"/>
+            <a:ext cx="11091672" cy="411480"/>
           </a:xfrm>
           <a:prstGeom prst="rect">
             <a:avLst/>
@@ -3170,7 +3170,7 @@
               </a:spcAft>
             </a:pPr>
             <a:r>
-              <a:rPr sz="1800" b="0" i="1">
+              <a:rPr sz="1500" b="0" i="1">
                 <a:solidFill>
                   <a:srgbClr val="6B6B6B"/>
                 </a:solidFill>
@@ -3189,7 +3189,7 @@
         </p:nvSpPr>
         <p:spPr>
           <a:xfrm>
-            <a:off x="5184648" y="2194560"/>
+            <a:off x="5184648" y="1600200"/>
             <a:ext cx="1828800" cy="25400"/>
           </a:xfrm>
           <a:prstGeom prst="rect">
@@ -3233,8 +3233,8 @@
         </p:nvSpPr>
         <p:spPr>
           <a:xfrm>
-            <a:off x="1645920" y="2697480"/>
-            <a:ext cx="54864" cy="3108960"/>
+            <a:off x="548640" y="1874519"/>
+            <a:ext cx="54864" cy="4160520"/>
           </a:xfrm>
           <a:prstGeom prst="rect">
             <a:avLst/>
@@ -3277,8 +3277,8 @@
         </p:nvSpPr>
         <p:spPr>
           <a:xfrm>
-            <a:off x="1920240" y="2697480"/>
-            <a:ext cx="8622792" cy="3108960"/>
+            <a:off x="822960" y="1874519"/>
+            <a:ext cx="5120640" cy="4160520"/>
           </a:xfrm>
           <a:prstGeom prst="rect">
             <a:avLst/>
@@ -3293,14 +3293,14 @@
           <a:p>
             <a:pPr algn="l">
               <a:lnSpc>
-                <a:spcPct val="135000"/>
+                <a:spcPct val="130000"/>
               </a:lnSpc>
               <a:spcAft>
                 <a:spcPts val="400"/>
               </a:spcAft>
             </a:pPr>
             <a:r>
-              <a:rPr sz="1800" b="0" i="0">
+              <a:rPr sz="1600" b="0" i="0">
                 <a:solidFill>
                   <a:srgbClr val="2C2C2C"/>
                 </a:solidFill>
@@ -3313,7 +3313,110 @@
       </p:sp>
       <p:sp>
         <p:nvSpPr>
-          <p:cNvPr id="7" name="TextBox 6"/>
+          <p:cNvPr id="7" name="Rounded Rectangle 6"/>
+          <p:cNvSpPr/>
+          <p:nvPr/>
+        </p:nvSpPr>
+        <p:spPr>
+          <a:xfrm>
+            <a:off x="6336792" y="1874519"/>
+            <a:ext cx="5303520" cy="3291840"/>
+          </a:xfrm>
+          <a:prstGeom prst="roundRect">
+            <a:avLst>
+              <a:gd name="adj" fmla="val 6000"/>
+            </a:avLst>
+          </a:prstGeom>
+          <a:solidFill>
+            <a:srgbClr val="EDE8DC"/>
+          </a:solidFill>
+          <a:ln w="12700">
+            <a:solidFill>
+              <a:srgbClr val="D4CFC6"/>
+            </a:solidFill>
+          </a:ln>
+          <a:effectLst/>
+        </p:spPr>
+        <p:style>
+          <a:lnRef idx="1">
+            <a:schemeClr val="accent1"/>
+          </a:lnRef>
+          <a:fillRef idx="3">
+            <a:schemeClr val="accent1"/>
+          </a:fillRef>
+          <a:effectRef idx="2">
+            <a:schemeClr val="accent1"/>
+          </a:effectRef>
+          <a:fontRef idx="minor">
+            <a:schemeClr val="lt1"/>
+          </a:fontRef>
+        </p:style>
+        <p:txBody>
+          <a:bodyPr rtlCol="0" anchor="ctr" wrap="square"/>
+          <a:lstStyle/>
+          <a:p>
+            <a:pPr algn="ctr">
+              <a:spcAft>
+                <a:spcPts val="400"/>
+              </a:spcAft>
+            </a:pPr>
+            <a:r>
+              <a:rPr sz="1400" b="0" i="1">
+                <a:solidFill>
+                  <a:srgbClr val="6B6B6B"/>
+                </a:solidFill>
+                <a:latin typeface="Calibri"/>
+              </a:rPr>
+              <a:t>[INSERT CHOROPLETH MAP SCREENSHOT]</a:t>
+            </a:r>
+          </a:p>
+        </p:txBody>
+      </p:sp>
+      <p:sp>
+        <p:nvSpPr>
+          <p:cNvPr id="8" name="TextBox 7"/>
+          <p:cNvSpPr txBox="1"/>
+          <p:nvPr/>
+        </p:nvSpPr>
+        <p:spPr>
+          <a:xfrm>
+            <a:off x="6336792" y="5257800"/>
+            <a:ext cx="5303520" cy="777240"/>
+          </a:xfrm>
+          <a:prstGeom prst="rect">
+            <a:avLst/>
+          </a:prstGeom>
+          <a:noFill/>
+        </p:spPr>
+        <p:txBody>
+          <a:bodyPr wrap="square">
+            <a:spAutoFit/>
+          </a:bodyPr>
+          <a:lstStyle/>
+          <a:p>
+            <a:pPr algn="ctr">
+              <a:lnSpc>
+                <a:spcPct val="120000"/>
+              </a:lnSpc>
+              <a:spcAft>
+                <a:spcPts val="400"/>
+              </a:spcAft>
+            </a:pPr>
+            <a:r>
+              <a:rPr sz="1200" b="0" i="1">
+                <a:solidFill>
+                  <a:srgbClr val="6B6B6B"/>
+                </a:solidFill>
+                <a:latin typeface="Calibri"/>
+              </a:rPr>
+              <a:t>Interactive choropleth map of all 290 Swedish municipalities colored by Opportunity Index score</a:t>
+            </a:r>
+          </a:p>
+        </p:txBody>
+      </p:sp>
+      <p:sp>
+        <p:nvSpPr>
+          <p:cNvPr id="9" name="TextBox 8"/>
           <p:cNvSpPr txBox="1"/>
           <p:nvPr/>
         </p:nvSpPr>
@@ -3352,7 +3455,7 @@
       </p:sp>
       <p:sp>
         <p:nvSpPr>
-          <p:cNvPr id="8" name="TextBox 7"/>
+          <p:cNvPr id="10" name="TextBox 9"/>
           <p:cNvSpPr txBox="1"/>
           <p:nvPr/>
         </p:nvSpPr>
@@ -3951,6 +4054,9 @@
           <a:lstStyle/>
           <a:p>
             <a:pPr algn="ctr">
+              <a:lnSpc>
+                <a:spcPct val="120000"/>
+              </a:lnSpc>
               <a:spcAft>
                 <a:spcPts val="400"/>
               </a:spcAft>
@@ -3962,7 +4068,7 @@
                 </a:solidFill>
                 <a:latin typeface="Calibri"/>
               </a:rPr>
-              <a:t>[INSERT DASHBOARD SCREENSHOT HERE]</a:t>
+              <a:t>[INSERT SCREENSHOT: Rankings tab with Born abroad filter]</a:t>
             </a:r>
           </a:p>
         </p:txBody>
@@ -3976,7 +4082,7 @@
         <p:spPr>
           <a:xfrm>
             <a:off x="7406640" y="4434840"/>
-            <a:ext cx="4233672" cy="457200"/>
+            <a:ext cx="4233672" cy="548640"/>
           </a:xfrm>
           <a:prstGeom prst="rect">
             <a:avLst/>
@@ -3990,18 +4096,21 @@
           <a:lstStyle/>
           <a:p>
             <a:pPr algn="ctr">
+              <a:lnSpc>
+                <a:spcPct val="115000"/>
+              </a:lnSpc>
               <a:spcAft>
                 <a:spcPts val="400"/>
               </a:spcAft>
             </a:pPr>
             <a:r>
-              <a:rPr sz="1200" b="0" i="1">
+              <a:rPr sz="1100" b="0" i="1">
                 <a:solidFill>
                   <a:srgbClr val="8B7355"/>
                 </a:solidFill>
                 <a:latin typeface="Calibri"/>
               </a:rPr>
-              <a:t>Live at: [STREAMLIT_URL] — deploy first, add URL after</a:t>
+              <a:t>Live at: https://swedish-municipality-explorer.streamlit.app</a:t>
             </a:r>
           </a:p>
         </p:txBody>
@@ -4202,8 +4311,8 @@
           <p:nvPr/>
         </p:nvGraphicFramePr>
         <p:xfrm>
-          <a:off x="548640" y="1188720"/>
-          <a:ext cx="11091672" cy="3291840"/>
+          <a:off x="548640" y="1097280"/>
+          <a:ext cx="11091672" cy="3017520"/>
         </p:xfrm>
         <a:graphic>
           <a:graphicData uri="http://schemas.openxmlformats.org/drawingml/2006/table">
@@ -4423,7 +4532,7 @@
                   </a:tcPr>
                 </a:tc>
               </a:tr>
-              <a:tr h="566928">
+              <a:tr h="512064">
                 <a:tc>
                   <a:txBody>
                     <a:bodyPr/>
@@ -4435,7 +4544,7 @@
                         </a:spcAft>
                       </a:pPr>
                       <a:r>
-                        <a:rPr sz="1200" b="0" i="0">
+                        <a:rPr sz="1100" b="0" i="0">
                           <a:solidFill>
                             <a:srgbClr val="2C2C2C"/>
                           </a:solidFill>
@@ -4486,7 +4595,7 @@
                         </a:spcAft>
                       </a:pPr>
                       <a:r>
-                        <a:rPr sz="1200" b="0" i="0">
+                        <a:rPr sz="1100" b="0" i="0">
                           <a:solidFill>
                             <a:srgbClr val="2C2C2C"/>
                           </a:solidFill>
@@ -4537,7 +4646,7 @@
                         </a:spcAft>
                       </a:pPr>
                       <a:r>
-                        <a:rPr sz="1200" b="0" i="0">
+                        <a:rPr sz="1100" b="0" i="0">
                           <a:solidFill>
                             <a:srgbClr val="2C2C2C"/>
                           </a:solidFill>
@@ -4588,7 +4697,7 @@
                         </a:spcAft>
                       </a:pPr>
                       <a:r>
-                        <a:rPr sz="1200" b="0" i="0">
+                        <a:rPr sz="1100" b="0" i="0">
                           <a:solidFill>
                             <a:srgbClr val="2C2C2C"/>
                           </a:solidFill>
@@ -4629,7 +4738,7 @@
                   </a:tcPr>
                 </a:tc>
               </a:tr>
-              <a:tr h="566928">
+              <a:tr h="512064">
                 <a:tc>
                   <a:txBody>
                     <a:bodyPr/>
@@ -4641,7 +4750,7 @@
                         </a:spcAft>
                       </a:pPr>
                       <a:r>
-                        <a:rPr sz="1200" b="0" i="0">
+                        <a:rPr sz="1100" b="0" i="0">
                           <a:solidFill>
                             <a:srgbClr val="2C2C2C"/>
                           </a:solidFill>
@@ -4692,7 +4801,7 @@
                         </a:spcAft>
                       </a:pPr>
                       <a:r>
-                        <a:rPr sz="1200" b="0" i="0">
+                        <a:rPr sz="1100" b="0" i="0">
                           <a:solidFill>
                             <a:srgbClr val="2C2C2C"/>
                           </a:solidFill>
@@ -4743,7 +4852,7 @@
                         </a:spcAft>
                       </a:pPr>
                       <a:r>
-                        <a:rPr sz="1200" b="0" i="0">
+                        <a:rPr sz="1100" b="0" i="0">
                           <a:solidFill>
                             <a:srgbClr val="2C2C2C"/>
                           </a:solidFill>
@@ -4794,7 +4903,7 @@
                         </a:spcAft>
                       </a:pPr>
                       <a:r>
-                        <a:rPr sz="1200" b="0" i="0">
+                        <a:rPr sz="1100" b="0" i="0">
                           <a:solidFill>
                             <a:srgbClr val="2C2C2C"/>
                           </a:solidFill>
@@ -4835,7 +4944,7 @@
                   </a:tcPr>
                 </a:tc>
               </a:tr>
-              <a:tr h="566928">
+              <a:tr h="512064">
                 <a:tc>
                   <a:txBody>
                     <a:bodyPr/>
@@ -4847,7 +4956,7 @@
                         </a:spcAft>
                       </a:pPr>
                       <a:r>
-                        <a:rPr sz="1200" b="0" i="0">
+                        <a:rPr sz="1100" b="0" i="0">
                           <a:solidFill>
                             <a:srgbClr val="2C2C2C"/>
                           </a:solidFill>
@@ -4898,7 +5007,7 @@
                         </a:spcAft>
                       </a:pPr>
                       <a:r>
-                        <a:rPr sz="1200" b="0" i="0">
+                        <a:rPr sz="1100" b="0" i="0">
                           <a:solidFill>
                             <a:srgbClr val="2C2C2C"/>
                           </a:solidFill>
@@ -4949,7 +5058,7 @@
                         </a:spcAft>
                       </a:pPr>
                       <a:r>
-                        <a:rPr sz="1200" b="0" i="0">
+                        <a:rPr sz="1100" b="0" i="0">
                           <a:solidFill>
                             <a:srgbClr val="2C2C2C"/>
                           </a:solidFill>
@@ -5000,7 +5109,7 @@
                         </a:spcAft>
                       </a:pPr>
                       <a:r>
-                        <a:rPr sz="1200" b="0" i="0">
+                        <a:rPr sz="1100" b="0" i="0">
                           <a:solidFill>
                             <a:srgbClr val="2C2C2C"/>
                           </a:solidFill>
@@ -5041,7 +5150,7 @@
                   </a:tcPr>
                 </a:tc>
               </a:tr>
-              <a:tr h="566928">
+              <a:tr h="512064">
                 <a:tc>
                   <a:txBody>
                     <a:bodyPr/>
@@ -5053,7 +5162,7 @@
                         </a:spcAft>
                       </a:pPr>
                       <a:r>
-                        <a:rPr sz="1200" b="0" i="0">
+                        <a:rPr sz="1100" b="0" i="0">
                           <a:solidFill>
                             <a:srgbClr val="2C2C2C"/>
                           </a:solidFill>
@@ -5104,7 +5213,7 @@
                         </a:spcAft>
                       </a:pPr>
                       <a:r>
-                        <a:rPr sz="1200" b="0" i="0">
+                        <a:rPr sz="1100" b="0" i="0">
                           <a:solidFill>
                             <a:srgbClr val="2C2C2C"/>
                           </a:solidFill>
@@ -5155,7 +5264,7 @@
                         </a:spcAft>
                       </a:pPr>
                       <a:r>
-                        <a:rPr sz="1200" b="0" i="0">
+                        <a:rPr sz="1100" b="0" i="0">
                           <a:solidFill>
                             <a:srgbClr val="2C2C2C"/>
                           </a:solidFill>
@@ -5206,7 +5315,7 @@
                         </a:spcAft>
                       </a:pPr>
                       <a:r>
-                        <a:rPr sz="1200" b="0" i="0">
+                        <a:rPr sz="1100" b="0" i="0">
                           <a:solidFill>
                             <a:srgbClr val="2C2C2C"/>
                           </a:solidFill>
@@ -5247,7 +5356,7 @@
                   </a:tcPr>
                 </a:tc>
               </a:tr>
-              <a:tr h="566928">
+              <a:tr h="512064">
                 <a:tc>
                   <a:txBody>
                     <a:bodyPr/>
@@ -5259,7 +5368,7 @@
                         </a:spcAft>
                       </a:pPr>
                       <a:r>
-                        <a:rPr sz="1200" b="0" i="0">
+                        <a:rPr sz="1100" b="0" i="0">
                           <a:solidFill>
                             <a:srgbClr val="2C2C2C"/>
                           </a:solidFill>
@@ -5310,7 +5419,7 @@
                         </a:spcAft>
                       </a:pPr>
                       <a:r>
-                        <a:rPr sz="1200" b="0" i="0">
+                        <a:rPr sz="1100" b="0" i="0">
                           <a:solidFill>
                             <a:srgbClr val="2C2C2C"/>
                           </a:solidFill>
@@ -5361,7 +5470,7 @@
                         </a:spcAft>
                       </a:pPr>
                       <a:r>
-                        <a:rPr sz="1200" b="0" i="0">
+                        <a:rPr sz="1100" b="0" i="0">
                           <a:solidFill>
                             <a:srgbClr val="2C2C2C"/>
                           </a:solidFill>
@@ -5412,7 +5521,7 @@
                         </a:spcAft>
                       </a:pPr>
                       <a:r>
-                        <a:rPr sz="1200" b="0" i="0">
+                        <a:rPr sz="1100" b="0" i="0">
                           <a:solidFill>
                             <a:srgbClr val="2C2C2C"/>
                           </a:solidFill>
@@ -5465,8 +5574,8 @@
         </p:nvSpPr>
         <p:spPr>
           <a:xfrm>
-            <a:off x="548640" y="4617720"/>
-            <a:ext cx="11091672" cy="457200"/>
+            <a:off x="548640" y="4206240"/>
+            <a:ext cx="11091672" cy="365760"/>
           </a:xfrm>
           <a:prstGeom prst="rect">
             <a:avLst/>
@@ -5504,8 +5613,8 @@
         </p:nvSpPr>
         <p:spPr>
           <a:xfrm>
-            <a:off x="548640" y="5212080"/>
-            <a:ext cx="54864" cy="914400"/>
+            <a:off x="548640" y="4617720"/>
+            <a:ext cx="54864" cy="777240"/>
           </a:xfrm>
           <a:prstGeom prst="rect">
             <a:avLst/>
@@ -5548,8 +5657,8 @@
         </p:nvSpPr>
         <p:spPr>
           <a:xfrm>
-            <a:off x="777240" y="5212080"/>
-            <a:ext cx="10863072" cy="914400"/>
+            <a:off x="777240" y="4617720"/>
+            <a:ext cx="10863072" cy="777240"/>
           </a:xfrm>
           <a:prstGeom prst="rect">
             <a:avLst/>
@@ -5564,14 +5673,14 @@
           <a:p>
             <a:pPr algn="l">
               <a:lnSpc>
-                <a:spcPct val="120000"/>
+                <a:spcPct val="115000"/>
               </a:lnSpc>
               <a:spcAft>
                 <a:spcPts val="400"/>
               </a:spcAft>
             </a:pPr>
             <a:r>
-              <a:rPr sz="1300" b="1" i="0">
+              <a:rPr sz="1200" b="1" i="0">
                 <a:solidFill>
                   <a:srgbClr val="8B7355"/>
                 </a:solidFill>
@@ -5584,7 +5693,93 @@
       </p:sp>
       <p:sp>
         <p:nvSpPr>
-          <p:cNvPr id="8" name="TextBox 7"/>
+          <p:cNvPr id="8" name="Rectangle 7"/>
+          <p:cNvSpPr/>
+          <p:nvPr/>
+        </p:nvSpPr>
+        <p:spPr>
+          <a:xfrm>
+            <a:off x="548640" y="5486400"/>
+            <a:ext cx="54864" cy="868680"/>
+          </a:xfrm>
+          <a:prstGeom prst="rect">
+            <a:avLst/>
+          </a:prstGeom>
+          <a:solidFill>
+            <a:srgbClr val="D4CFC6"/>
+          </a:solidFill>
+          <a:ln>
+            <a:noFill/>
+          </a:ln>
+          <a:effectLst/>
+        </p:spPr>
+        <p:style>
+          <a:lnRef idx="1">
+            <a:schemeClr val="accent1"/>
+          </a:lnRef>
+          <a:fillRef idx="3">
+            <a:schemeClr val="accent1"/>
+          </a:fillRef>
+          <a:effectRef idx="2">
+            <a:schemeClr val="accent1"/>
+          </a:effectRef>
+          <a:fontRef idx="minor">
+            <a:schemeClr val="lt1"/>
+          </a:fontRef>
+        </p:style>
+        <p:txBody>
+          <a:bodyPr rtlCol="0" anchor="ctr"/>
+          <a:lstStyle/>
+          <a:p>
+            <a:pPr algn="ctr"/>
+          </a:p>
+        </p:txBody>
+      </p:sp>
+      <p:sp>
+        <p:nvSpPr>
+          <p:cNvPr id="9" name="TextBox 8"/>
+          <p:cNvSpPr txBox="1"/>
+          <p:nvPr/>
+        </p:nvSpPr>
+        <p:spPr>
+          <a:xfrm>
+            <a:off x="777240" y="5486400"/>
+            <a:ext cx="10863072" cy="868680"/>
+          </a:xfrm>
+          <a:prstGeom prst="rect">
+            <a:avLst/>
+          </a:prstGeom>
+          <a:noFill/>
+        </p:spPr>
+        <p:txBody>
+          <a:bodyPr wrap="square" anchor="ctr">
+            <a:spAutoFit/>
+          </a:bodyPr>
+          <a:lstStyle/>
+          <a:p>
+            <a:pPr algn="l">
+              <a:lnSpc>
+                <a:spcPct val="115000"/>
+              </a:lnSpc>
+              <a:spcAft>
+                <a:spcPts val="400"/>
+              </a:spcAft>
+            </a:pPr>
+            <a:r>
+              <a:rPr sz="1100" b="0" i="1">
+                <a:solidFill>
+                  <a:srgbClr val="6B6B6B"/>
+                </a:solidFill>
+                <a:latin typeface="Calibri"/>
+              </a:rPr>
+              <a:t>Note: Employment path was replaced from LE0105Sysselsattn02N to RamsForvInt04N, and Education path was replaced from UtbSUNBefN to UtbBefRegionR after original endpoints returned 400 errors — documented in docs/agents/agent2_ingestor.md</a:t>
+            </a:r>
+          </a:p>
+        </p:txBody>
+      </p:sp>
+      <p:sp>
+        <p:nvSpPr>
+          <p:cNvPr id="10" name="TextBox 9"/>
           <p:cNvSpPr txBox="1"/>
           <p:nvPr/>
         </p:nvSpPr>
@@ -5623,7 +5818,7 @@
       </p:sp>
       <p:sp>
         <p:nvSpPr>
-          <p:cNvPr id="9" name="TextBox 8"/>
+          <p:cNvPr id="11" name="TextBox 10"/>
           <p:cNvSpPr txBox="1"/>
           <p:nvPr/>
         </p:nvSpPr>
@@ -8475,8 +8670,8 @@
       </p:sp>
       <p:sp>
         <p:nvSpPr>
-          <p:cNvPr id="9" name="TextBox 8"/>
-          <p:cNvSpPr txBox="1"/>
+          <p:cNvPr id="9" name="Rounded Rectangle 8"/>
+          <p:cNvSpPr/>
           <p:nvPr/>
         </p:nvSpPr>
         <p:spPr>
@@ -8484,49 +8679,55 @@
             <a:off x="548640" y="5349240"/>
             <a:ext cx="11091672" cy="1005840"/>
           </a:xfrm>
-          <a:prstGeom prst="rect">
-            <a:avLst/>
+          <a:prstGeom prst="roundRect">
+            <a:avLst>
+              <a:gd name="adj" fmla="val 6000"/>
+            </a:avLst>
           </a:prstGeom>
-          <a:noFill/>
+          <a:solidFill>
+            <a:srgbClr val="8B7355"/>
+          </a:solidFill>
+          <a:ln w="12700">
+            <a:solidFill>
+              <a:srgbClr val="8B7355"/>
+            </a:solidFill>
+          </a:ln>
+          <a:effectLst/>
         </p:spPr>
-        <p:txBody>
-          <a:bodyPr wrap="square">
-            <a:spAutoFit/>
-          </a:bodyPr>
-          <a:lstStyle/>
-          <a:p>
-            <a:pPr algn="l">
-              <a:spcAft>
-                <a:spcPts val="200"/>
-              </a:spcAft>
-            </a:pPr>
-            <a:r>
-              <a:rPr sz="1300" b="1" i="0">
-                <a:solidFill>
-                  <a:srgbClr val="8B7355"/>
-                </a:solidFill>
-                <a:latin typeface="Calibri"/>
-              </a:rPr>
-              <a:t>What 0–100 means</a:t>
-            </a:r>
-          </a:p>
+        <p:style>
+          <a:lnRef idx="1">
+            <a:schemeClr val="accent1"/>
+          </a:lnRef>
+          <a:fillRef idx="3">
+            <a:schemeClr val="accent1"/>
+          </a:fillRef>
+          <a:effectRef idx="2">
+            <a:schemeClr val="accent1"/>
+          </a:effectRef>
+          <a:fontRef idx="minor">
+            <a:schemeClr val="lt1"/>
+          </a:fontRef>
+        </p:style>
+        <p:txBody>
+          <a:bodyPr rtlCol="0" anchor="ctr" wrap="square" lIns="228600" rIns="228600"/>
+          <a:lstStyle/>
           <a:p>
             <a:pPr algn="l">
               <a:lnSpc>
-                <a:spcPct val="120000"/>
+                <a:spcPct val="125000"/>
               </a:lnSpc>
               <a:spcAft>
                 <a:spcPts val="400"/>
               </a:spcAft>
             </a:pPr>
             <a:r>
-              <a:rPr sz="1200" b="0" i="0">
-                <a:solidFill>
-                  <a:srgbClr val="2C2C2C"/>
-                </a:solidFill>
-                <a:latin typeface="Calibri"/>
-              </a:rPr>
-              <a:t>Each component score is a percentile: 0 is the lowest value among all 290 municipalities, 100 is the highest — so the Opportunity Index lands on the same 0–100 scale. No municipality dominates every dimension: Danderyd scores 100 on income (the highest median in Sweden) but only 56 on employment, roughly mid-pack within its population group. The Opportunity Index captures that trade-off in a single, comparable number.</a:t>
+              <a:rPr sz="1300" b="0" i="0">
+                <a:solidFill>
+                  <a:srgbClr val="FFFFFF"/>
+                </a:solidFill>
+                <a:latin typeface="Calibri"/>
+              </a:rPr>
+              <a:t>Think of each score as a percentile — a score of 75 means this municipality outperforms 75% of Sweden's 290 municipalities on that dimension. Danderyd scores 100 on income (highest median in Sweden) but only 56 on employment — its large wealthy retired population aren't in the workforce. The index captures that trade-off in one number.</a:t>
             </a:r>
           </a:p>
         </p:txBody>
@@ -8755,7 +8956,7 @@
                 </a:solidFill>
                 <a:latin typeface="Calibri"/>
               </a:rPr>
-              <a:t>Switching the Population group filter from “All residents” to “Born abroad” barely moves most municipalities — but for a handful, the gap tells a real story.</a:t>
+              <a:t>Switch the Population group filter from 'All residents' to 'Born abroad' and watch the rankings reshuffle — this is the moment the dashboard was built for.</a:t>
             </a:r>
           </a:p>
         </p:txBody>
@@ -10592,8 +10793,8 @@
       </p:sp>
       <p:sp>
         <p:nvSpPr>
-          <p:cNvPr id="8" name="TextBox 7"/>
-          <p:cNvSpPr txBox="1"/>
+          <p:cNvPr id="8" name="Rounded Rectangle 7"/>
+          <p:cNvSpPr/>
           <p:nvPr/>
         </p:nvSpPr>
         <p:spPr>
@@ -10601,15 +10802,37 @@
             <a:off x="548640" y="5806440"/>
             <a:ext cx="11091672" cy="640080"/>
           </a:xfrm>
-          <a:prstGeom prst="rect">
-            <a:avLst/>
+          <a:prstGeom prst="roundRect">
+            <a:avLst>
+              <a:gd name="adj" fmla="val 6000"/>
+            </a:avLst>
           </a:prstGeom>
-          <a:noFill/>
+          <a:solidFill>
+            <a:srgbClr val="EDE8DC"/>
+          </a:solidFill>
+          <a:ln w="12700">
+            <a:solidFill>
+              <a:srgbClr val="D4CFC6"/>
+            </a:solidFill>
+          </a:ln>
+          <a:effectLst/>
         </p:spPr>
-        <p:txBody>
-          <a:bodyPr wrap="square">
-            <a:spAutoFit/>
-          </a:bodyPr>
+        <p:style>
+          <a:lnRef idx="1">
+            <a:schemeClr val="accent1"/>
+          </a:lnRef>
+          <a:fillRef idx="3">
+            <a:schemeClr val="accent1"/>
+          </a:fillRef>
+          <a:effectRef idx="2">
+            <a:schemeClr val="accent1"/>
+          </a:effectRef>
+          <a:fontRef idx="minor">
+            <a:schemeClr val="lt1"/>
+          </a:fontRef>
+        </p:style>
+        <p:txBody>
+          <a:bodyPr rtlCol="0" anchor="ctr" wrap="square"/>
           <a:lstStyle/>
           <a:p>
             <a:pPr algn="ctr">
@@ -10621,13 +10844,13 @@
               </a:spcAft>
             </a:pPr>
             <a:r>
-              <a:rPr sz="1100" b="0" i="1">
-                <a:solidFill>
-                  <a:srgbClr val="6B6B6B"/>
-                </a:solidFill>
-                <a:latin typeface="Calibri"/>
-              </a:rPr>
-              <a:t>For the large majority of Sweden's 290 municipalities, the overall rank and the born-abroad rank are nearly identical — meaning opportunity, as measured here, is largely independent of where a resident was born. The exceptions above are exactly where this dashboard adds value: invisible in national averages, visible only at the municipality level.</a:t>
+              <a:rPr sz="1100" b="0" i="0">
+                <a:solidFill>
+                  <a:srgbClr val="2C2C2C"/>
+                </a:solidFill>
+                <a:latin typeface="Calibri"/>
+              </a:rPr>
+              <a:t>For the large majority of Sweden's 290 municipalities, overall rank and born-abroad rank are nearly identical — meaning opportunity is largely independent of birthplace. The exceptions are where this dashboard adds value: invisible in national averages, visible only at municipality level.</a:t>
             </a:r>
           </a:p>
         </p:txBody>
@@ -11249,7 +11472,7 @@
                 </a:solidFill>
                 <a:latin typeface="Calibri"/>
               </a:rPr>
-              <a:t>[STREAMLIT_URL — add after deployment]</a:t>
+              <a:t>https://swedish-municipality-explorer.streamlit.app</a:t>
             </a:r>
           </a:p>
         </p:txBody>
@@ -11310,7 +11533,7 @@
                 </a:solidFill>
                 <a:latin typeface="Calibri"/>
               </a:rPr>
-              <a:t>Source Code</a:t>
+              <a:t>GitHub</a:t>
             </a:r>
           </a:p>
           <a:p>
@@ -11403,7 +11626,7 @@
                 </a:solidFill>
                 <a:latin typeface="Calibri"/>
               </a:rPr>
-              <a:t>linkedin.com/in/[handle]</a:t>
+              <a:t>linkedin.com/in/waldeannelson/</a:t>
             </a:r>
           </a:p>
         </p:txBody>

</xml_diff>